<commit_message>
Add Mastery Path reviews per CFA (trigger below 2.67); students see 'at least a 3'
Co-Authored-By: Claude Sonnet 5.5 <noreply@anthropic.com>
Claude-Session: https://claude.ai/code/session_019ERqgdpGTz94JPExxdNzgB
</commit_message>
<xml_diff>
--- a/assessments/HS-LS1-1/slides/Day_7_Review_and_back_to_the_cat.pptx
+++ b/assessments/HS-LS1-1/slides/Day_7_Review_and_back_to_the_cat.pptx
@@ -3388,7 +3388,22 @@
               </a:defRPr>
             </a:pPr>
             <a:r>
-              <a:t>• Scored below a 3 on a CFA? Do the matching section of the Review page.</a:t>
+              <a:t>• Your goal on every CFA is at least a 3.</a:t>
+            </a:r>
+          </a:p>
+          <a:p>
+            <a:pPr>
+              <a:spcAft>
+                <a:spcPts val="1000"/>
+              </a:spcAft>
+              <a:defRPr sz="2600">
+                <a:solidFill>
+                  <a:srgbClr val="222222"/>
+                </a:solidFill>
+              </a:defRPr>
+            </a:pPr>
+            <a:r>
+              <a:t>• Below a 3? A review opened in your Mastery Path. Do it.</a:t>
             </a:r>
           </a:p>
           <a:p>
@@ -3572,7 +3587,7 @@
               </a:defRPr>
             </a:pPr>
             <a:r>
-              <a:t>• Open the Review page in Canvas.</a:t>
+              <a:t>• Do the Mastery Path reviews that opened for you.</a:t>
             </a:r>
           </a:p>
           <a:p>
@@ -3587,7 +3602,7 @@
               </a:defRPr>
             </a:pPr>
             <a:r>
-              <a:t>• Do Vocabulary, then the sections for the CFAs you need.</a:t>
+              <a:t>• Open the Review page in Canvas and do Vocabulary.</a:t>
             </a:r>
           </a:p>
           <a:p>

</xml_diff>